<commit_message>
Refine disease slides against ATLS 11th ed.
Add special-population needle sites, flail definitions and analgesic
options, pediatric contusion note, and physiology-driven surgery for
massive hemothorax; tighten wording and update speaker notes.

Co-Authored-By: Claude Opus 5.5 <noreply@anthropic.com>
Claude-Session: https://claude.ai/code/session_01U9i4B9LK3fqJ6vhMxsMjmp
</commit_message>
<xml_diff>
--- a/B_breathing_ATLS_16min.pptx
+++ b/B_breathing_ATLS_16min.pptx
@@ -854,14 +854,17 @@
           <a:lstStyle/>
           <a:p>
             <a:r>
-              <a:rPr lang="en-US"/>
               <a:t>สรุปว่าโรคนี้คืออะไร: ลมรั่วแบบ one-way valve ค้างอยู่ใน pleural space ปอดแฟบ mediastinum ถูกดันไปอีกข้าง กด vena cava ทำให้ venous return และ cardiac output ลด จึงเกิด shock กระทบทั้ง B และ C พูด — Diagnosis: "ประโยคที่ต้องจำ: tension pneumothorax เป็น clinical diagnosis ห้ามรอ CXR หรือ ultrasound" "วินิจฉัยจาก 3 อย่าง คือ mechanism ที่เข้าได้ เสียงหายใจหายไปข้างเดียว และความดันต่ำ" "อาการเสริม คือหอบ ใจสั่น SpO2 ตก เคาะโปร่ง trachea เบนไปฝั่งตรงข้าม ซึ่งมักเห็นยาก ให้ดูที่ sternal notch และ neck vein โป่ง แต่ถ้ามีเสียเลือดร่วม neck vein อาจแฟบ" "(ชี้รูปบน) นี่คือ CXR ของ right tension pneumothorax จะเห็นว่า trachea ถูกดันไปทางซ้าย แต่ในชีวิตจริงเราควรรักษาไปแล้วก่อนได้ film นี้" "อีกสถานการณ์ที่ต้องนึกถึง คือผู้ป่วยใส่ท่อแล้วทรุดลงทันทีหลังเริ่ม bag หรือต่อ ventilator" พูด — Management: "ให้ O2 non-rebreather 15 ลิตรต่อนาที แล้ว decompress ทันที" "(ชี้รูปล่าง) Needle decompression ใช้เข็ม over-the-needle อย่างน้อย 14G มี 2 ตำแหน่ง คือ ICS 5 ระหว่าง anterior กับ mid-axillary line ประมาณระดับ IMF หรือ ICS 2 ที่ midclavicular line แทงชิดขอบบนของซี่โครงเพื่อเลี่ยง NV bundle" "ถ้าผนังอกหนาหรือผู้ป่วยอ้วน เข็มสั้นมักไม่ถึง pleura ให้ใช้ catheter ที่ยาวขึ้น หรือทำ finger thoracostomy คือกรีดผิวที่ ICS 5 AAL–MAL แล้วใช้นิ้วเข้าไปใน pleura" "ไม่ว่าวิธีไหน ต้องตามด้วย chest tube เสมอ เพราะ tension กลับมาได้ สาย 14 Fr ได้ผลเท่าสายใหญ่สำหรับ pneumothorax" "ของที่ต้องเตรียม: น้ำยาฆ่าเชื้อ, 1% lidocaine สำหรับฉีดชา, มีด, curved clamp, สาย chest tube และระบบ drain" ถ้าโดนถาม: "ทำไม ICS 5 — เพราะผนังอกบางกว่า แทงถึง pleura ได้มากกว่าในผู้ใหญ่ส่วนใหญ่ แต่ ATLS 11th ให้เลือกได้ทั้ง 2 ตำแหน่งตามตัวผู้ป่วย เช่นคนท้องอาจเลือก ICS 2" ส่งต่อ: "ภาวะต่อไปเป็น pneumothorax อีกแบบที่เห็นได้จากภายนอก"</a:t>
             </a:r>
           </a:p>
           <a:p>
             <a:r>
-              <a:rPr lang="en-US"/>
               <a:t>15</a:t>
+            </a:r>
+          </a:p>
+          <a:p>
+            <a:r>
+              <a:t>เพิ่ม (บรรทัดล่าง): "คนท้อง มดลูกดัน diaphragm ขึ้น ให้เลื่อนตำแหน่งขึ้น 1–2 ช่องซี่โครง หรือใช้ ICS 2 MCL ส่วนเด็กทำที่ระดับ IMF หรือสูงกว่าเล็กน้อย"</a:t>
             </a:r>
           </a:p>
         </p:txBody>
@@ -1290,14 +1293,17 @@
           <a:lstStyle/>
           <a:p>
             <a:r>
-              <a:rPr lang="en-US"/>
               <a:t>สรุปว่าโรคนี้คืออะไร: เลือดสะสมใน pleural space จากปอด intercostal artery ซี่โครงหัก อวัยวะในอก หรือจากช่องท้องผ่านรูที่ diaphragm ถ้ามากจนความดันตกเรียก massive hemothorax ความดันตกจาก 2 กลไก คือเสียเลือดจริง และเลือดกด mediastinum ทำให้ venous return ลด พูด — Diagnosis: "ตรวจจะพบเสียงหายใจลด เคาะทึบ ซึ่งต่างจาก tension pneumothorax ที่เคาะโปร่ง ร่วมกับ hemorrhagic shock คือใจเร็ว ความดันตก" "neck vein จะแฟบเพราะเสียเลือด trachea อยู่กลาง ยกเว้นเลือดเยอะจนเกิด tension" "(ชี้รูป) นี่คือ CXR ของ massive hemothorax แต่ระวัง film ท่านอนจะเห็นแค่ฝ้าๆ ทั้งข้าง เพราะเลือดไปกองด้านหลัง ต้องใช้ eFAST ช่วย และเลือดที่ออกมาจาก chest tube คือคำยืนยัน" พูด — Management (ทำพร้อมกันเป็นทีม): "ให้ O2 เปิดเส้นใหญ่ 2 เส้น อย่างน้อย 16G หรือใช้ IO แล้วส่ง type and crossmatch" "เปิด massive transfusion protocol ให้ PRC ต่อ plasma ต่อ platelet 1:1:1 หรือ whole blood ระหว่างรอเลือดตรงกรุ๊ปใช้ O-negative ในผู้หญิงวัยเจริญพันธุ์ และให้ AB plasma" "ให้ TXA 1 กรัม IV ภายใน 3 ชั่วโมงหลังบาดเจ็บ แล้วตามด้วยอีก 1 กรัมหยดใน 8 ชั่วโมง หรือให้ 2 กรัมครั้งเดียวก็ได้" "ทำ finger thoracostomy แล้วใส่ chest tube สายใหญ่ 24 Fr ขึ้นไป และ hemothorax ทุกรายที่มากกว่า 300 mL ควร drain เพื่อกันเลือดแข็งตัวจนเป็น trapped lung" "ตามศัลยแพทย์ตั้งแต่แรก" "อุ่นสารน้ำและเลือดถึง 39 องศา และให้ crystalloid น้อยที่สุด เพื่อกัน lethal triad" จุดเปลี่ยนของ 11th edition (เน้นเสียง): "เดิมเราใช้เกณฑ์ตัวเลข เช่นเลือดออก 1,500 mL ทันที หรือ 200 mL ต่อชั่วโมง ใน 11th edition ไม่ใช้ตัวเลข output แล้ว แต่ตัดสินผ่าตัดจาก physiology คือผู้ป่วยยัง shock อยู่ และมีเลือดออกต่อเนื่อง" ส่งต่อ: "ต่อไปเป็นบาดเจ็บของผนังอก flail chest"</a:t>
             </a:r>
           </a:p>
           <a:p>
             <a:r>
-              <a:rPr lang="en-US"/>
               <a:t>17</a:t>
+            </a:r>
+          </a:p>
+          <a:p>
+            <a:r>
+              <a:t>เพิ่ม: "การตัดสินใจผ่าตัดดูจาก physiology คือ shock และเลือดยังออกต่อ ไม่ได้ดูแค่ปริมาณเลือดจาก chest tube"</a:t>
             </a:r>
           </a:p>
         </p:txBody>
@@ -1508,14 +1514,17 @@
           <a:lstStyle/>
           <a:p>
             <a:r>
-              <a:rPr lang="en-US"/>
               <a:t>สรุปว่าโรคนี้คืออะไร: Radiographic flail คือซี่โครงหักอย่างน้อย 2 ซี่ ซี่ละอย่างน้อย 2 ตำแหน่ง ส่วน clinical flail คือเห็น paradoxical movement ชิ้นที่หลุดยุบเข้าตอนหายใจเข้าและโป่งออกตอนหายใจออก มี radiographic โดยไม่มี clinical ได้ แต่ไม่มีกรณีกลับกัน ปัญหาหลักคือปวดจนหายใจตื้น CO2 คั่ง ส่วน hypoxia รุนแรงมักมาจาก pulmonary contusion ข้างใต้ พูด — Diagnosis: "ผู้ป่วยจะปวดเวลาหายใจ หายใจตื้น พูดไม่จบประโยค ไม่อยากขยับตัว" "(ชี้รูปบน) มองหา paradoxical segment ชิ้นนี้ยุบเข้าตอนหายใจเข้า โป่งออกตอนหายใจออก แต่ถ้าผู้ป่วยใส่ ventilator แล้วจะเห็นยากมาก" "คลำเจ็บ มี crepitus RR เร็ว SpO2 ตก ABG จะเห็น CO2 สูงและ O2 ต่ำ" "(ชี้รูปล่าง) CXR เห็นซี่โครงหักหลายซี่ร่วมกับ contusion แต่ CT ดีที่สุดในการนับซี่และดูว่าหักกี่ตำแหน่ง" พูด — Management: "ATLS บอกว่าสาเหตุตายอันดับหนึ่งของซี่โครงหักคือ pneumonia เพราะปวดจนไอและหายใจลึกไม่ได้ ดังนั้นการคุมปวดคือการรักษา" "ให้ O2 และติดตาม SpO2, RR และ incentive spirometry เพื่อดู vital capacity" "ใช้ยาแบบ multimodal เน้น non-opioid ได้แก่ paracetamol, NSAIDs, ketamine ขนาดต่ำ และ IV lidocaine" "ร่วมกับ regional block เช่น thoracic epidural, serratus anterior block หรือ erector spinae plane block" "ลด opioid ทำ chest physiotherapy และให้ลุกเดินเร็ว" "ใส่ท่อเมื่อหายใจล้มเหลว hypoxia รุนแรง หรือต้องใช้ยาแก้ปวดแรงจนกดการหายใจ" "Surgical stabilization of rib fractures หรือ SSRF ช่วยในบางราย และให้ admit ตาม protocol ว่าควรอยู่ ICU หรือ ward" ขนาดยาทั่วไปในผู้ใหญ่ ถ้าโดนถาม (ไม่ได้มาจาก ATLS ให้เช็ค protocol รพ.): paracetamol 1 กรัมทุก 6 ชั่วโมง ไม่เกิน 4 กรัมต่อวัน, ibuprofen 400 mg ทุก 6–8 ชั่วโมงถ้าไม่มีข้อห้ามเรื่องไตหรือเลือดออก ส่งต่อ: "พูดถึง contusion ใต้ flail แล้ว มาดูเรื่องนี้ต่อ"</a:t>
             </a:r>
           </a:p>
           <a:p>
             <a:r>
-              <a:rPr lang="en-US"/>
               <a:t>18</a:t>
+            </a:r>
+          </a:p>
+          <a:p>
+            <a:r>
+              <a:t>เพิ่ม: "radiographic flail คือเห็นในภาพว่าซี่โครง ≥ 2 ซี่หัก ≥ 2 ตำแหน่ง ส่วน clinical flail คือเห็น paradoxical movement จริง ซึ่งอาจไม่เห็นถ้าผู้ป่วยใส่ ventilator" "สาเหตุตายหลักคือ pneumonia จากปวดจนหายใจลึกและไอไม่ได้ ยาแก้ปวดใช้แบบ multimodal ลด opioid: paracetamol, NSAIDs, ketamine, lidocaine และ regional block"</a:t>
             </a:r>
           </a:p>
         </p:txBody>
@@ -1726,14 +1735,17 @@
           <a:lstStyle/>
           <a:p>
             <a:r>
-              <a:rPr lang="en-US"/>
               <a:t>สรุปว่าโรคนี้คืออะไร: ปอดช้ำ คือการบาดเจ็บของ alveolar capillary โดยเนื้อปอดไม่ฉีก เลือดและน้ำเข้าไปใน alveoli ทำให้ V/Q mismatch, shunt และ compliance ลด เป็น intrathoracic injury ที่พบบ่อยที่สุด แย่ลงได้ใน 24–72 ชั่วโมง และในเด็กเกิดได้โดยไม่มีซี่โครงหักเพราะผนังอกยืดหยุ่น พูด — Diagnosis: "ช่วงแรกอาจไม่มีอาการเลย ต่อมาจะหอบ หายใจเร็ว SpO2 ตก ฟังได้ crackles ถ้ารุนแรงจะมี wheeze ไอ มีเสมหะปนเลือด" "(ชี้รูปบน) CXR จะเห็น infiltrate ที่ไม่ตาม lobe หรือ segment แต่โดยเฉลี่ยจะเห็นหลัง 6 ชั่วโมง บางรายช้าถึง 48 ชั่วโมง" "(ชี้รูปล่าง) CT ของผู้ป่วยคนเดียวกัน เห็นได้แทบทันที เป็น consolidation กับ ground-glass และปริมาตรปอดที่ช้ำสัมพันธ์กับ outcome" "อาการแย่สุดประมาณ 72 ชั่วโมง ต้องตรวจซ้ำและติดตาม SpO2 กับ ABG" พูด — Management: "ให้ O2 ให้ SpO2 อยู่ที่ 94 ถึง 98 เปอร์เซ็นต์" "หลีกเลี่ยงการให้น้ำเกิน เพราะปอดที่ช้ำบวมน้ำง่าย แต่ยังต้องประคอง circulation ถ้า shock ให้เลือด และให้ crystalloid อย่างระวัง" "ถ้าหายใจไม่ไหวให้ใส่ท่อ ตั้ง ventilator แบบ lung protective ตาม ATLS คือ tidal volume ไม่เกิน 6 mL/kg ของ ideal body weight, PEEP 5 และเริ่ม FiO2 100% แล้วลดตาม SpO2" "คุมปวด ทำ chest physiotherapy และ incentive spirometry เพราะประมาณ 20% เกิด pneumonia" ส่งต่อ: "ภาวะต่อไปพบน้อยแต่อันตรายมาก คือ tracheobronchial injury"</a:t>
             </a:r>
           </a:p>
           <a:p>
             <a:r>
-              <a:rPr lang="en-US"/>
               <a:t>19</a:t>
+            </a:r>
+          </a:p>
+          <a:p>
+            <a:r>
+              <a:t>เพิ่ม: "ในเด็กผนังอกยืดหยุ่น จึงเกิด contusion ได้แม้ไม่มีซี่โครงหัก"</a:t>
             </a:r>
           </a:p>
         </p:txBody>
@@ -8792,7 +8804,7 @@
                 <a:cs typeface="DM Sans Bold"/>
                 <a:sym typeface="DM Sans Bold"/>
               </a:rPr>
-              <a:t>Thoracotomy</a:t>
+              <a:t>Surgery</a:t>
             </a:r>
             <a:r>
               <a:rPr lang="en-US" sz="1950">
@@ -8816,7 +8828,7 @@
                 <a:cs typeface="DM Sans Bold"/>
                 <a:sym typeface="DM Sans Bold"/>
               </a:rPr>
-              <a:t>physiologic status (shock)</a:t>
+              <a:t>physiology &amp; ongoing bleeding</a:t>
             </a:r>
             <a:r>
               <a:rPr lang="en-US" sz="1950">
@@ -8828,19 +8840,7 @@
                 <a:cs typeface="DM Sans"/>
                 <a:sym typeface="DM Sans"/>
               </a:rPr>
-              <a:t> &amp; </a:t>
-            </a:r>
-            <a:r>
-              <a:rPr lang="en-US" sz="1950" b="true">
-                <a:solidFill>
-                  <a:srgbClr val="FFFFFF"/>
-                </a:solidFill>
-                <a:latin typeface="DM Sans Bold"/>
-                <a:ea typeface="DM Sans Bold"/>
-                <a:cs typeface="DM Sans Bold"/>
-                <a:sym typeface="DM Sans Bold"/>
-              </a:rPr>
-              <a:t>ongoing bleeding</a:t>
+              <a:t>, not tube output alone</a:t>
             </a:r>
           </a:p>
         </p:txBody>
@@ -9735,6 +9735,10 @@
               <a:srgbClr val="FFDAD1"/>
             </a:solidFill>
           </p:spPr>
+          <p:txBody>
+            <a:bodyPr/>
+            <a:p/>
+          </p:txBody>
         </p:sp>
         <p:sp>
           <p:nvSpPr>
@@ -9770,7 +9774,7 @@
                   <a:cs typeface="Droid Serif Bold"/>
                   <a:sym typeface="Droid Serif Bold"/>
                 </a:rPr>
-                <a:t>≥ 2 adjacent ribs</a:t>
+                <a:t>Radiographic</a:t>
               </a:r>
               <a:r>
                 <a:rPr lang="en-US" sz="2100">
@@ -9782,7 +9786,7 @@
                   <a:cs typeface="Droid Serif"/>
                   <a:sym typeface="Droid Serif"/>
                 </a:rPr>
-                <a:t> broken in </a:t>
+                <a:t>: ≥ 2 ribs broken in ≥ 2 places · </a:t>
               </a:r>
               <a:r>
                 <a:rPr lang="en-US" sz="2100" b="true">
@@ -9794,7 +9798,7 @@
                   <a:cs typeface="Droid Serif Bold"/>
                   <a:sym typeface="Droid Serif Bold"/>
                 </a:rPr>
-                <a:t>≥ 2 places</a:t>
+                <a:t>Clinical</a:t>
               </a:r>
               <a:r>
                 <a:rPr lang="en-US" sz="2100">
@@ -9806,19 +9810,7 @@
                   <a:cs typeface="Droid Serif"/>
                   <a:sym typeface="Droid Serif"/>
                 </a:rPr>
-                <a:t> → </a:t>
-              </a:r>
-              <a:r>
-                <a:rPr lang="en-US" sz="2100" b="true">
-                  <a:solidFill>
-                    <a:srgbClr val="E74B2F"/>
-                  </a:solidFill>
-                  <a:latin typeface="Droid Serif Bold"/>
-                  <a:ea typeface="Droid Serif Bold"/>
-                  <a:cs typeface="Droid Serif Bold"/>
-                  <a:sym typeface="Droid Serif Bold"/>
-                </a:rPr>
-                <a:t>paradoxical movement</a:t>
+                <a:t>: paradoxical movement</a:t>
               </a:r>
             </a:p>
           </p:txBody>
@@ -10326,6 +10318,18 @@
               <a:buChar char="•"/>
             </a:pPr>
             <a:r>
+              <a:rPr lang="en-US" sz="1950" b="true">
+                <a:solidFill>
+                  <a:srgbClr val="1F1210"/>
+                </a:solidFill>
+                <a:latin typeface="DM Sans Bold"/>
+                <a:ea typeface="DM Sans Bold"/>
+                <a:cs typeface="DM Sans Bold"/>
+                <a:sym typeface="DM Sans Bold"/>
+              </a:rPr>
+              <a:t>Paradoxical chest movement</a:t>
+            </a:r>
+            <a:r>
               <a:rPr lang="en-US" sz="1950">
                 <a:solidFill>
                   <a:srgbClr val="1F1210"/>
@@ -10335,31 +10339,7 @@
                 <a:cs typeface="DM Sans"/>
                 <a:sym typeface="DM Sans"/>
               </a:rPr>
-              <a:t>Severe pain, splinting &amp; </a:t>
-            </a:r>
-            <a:r>
-              <a:rPr lang="en-US" sz="1950" b="true">
-                <a:solidFill>
-                  <a:srgbClr val="1F1210"/>
-                </a:solidFill>
-                <a:latin typeface="DM Sans Bold"/>
-                <a:ea typeface="DM Sans Bold"/>
-                <a:cs typeface="DM Sans Bold"/>
-                <a:sym typeface="DM Sans Bold"/>
-              </a:rPr>
-              <a:t>paradoxical chest movement</a:t>
-            </a:r>
-            <a:r>
-              <a:rPr lang="en-US" sz="1950">
-                <a:solidFill>
-                  <a:srgbClr val="1F1210"/>
-                </a:solidFill>
-                <a:latin typeface="DM Sans"/>
-                <a:ea typeface="DM Sans"/>
-                <a:cs typeface="DM Sans"/>
-                <a:sym typeface="DM Sans"/>
-              </a:rPr>
-              <a:t> (clinical flail)</a:t>
+              <a:t> (clinical flail) — may be masked by PPV</a:t>
             </a:r>
           </a:p>
           <a:p>
@@ -10383,7 +10363,7 @@
                 <a:cs typeface="DM Sans"/>
                 <a:sym typeface="DM Sans"/>
               </a:rPr>
-              <a:t>Severe hypoxemia driven by underlying </a:t>
+              <a:t>Pain, splinting, crepitus; </a:t>
             </a:r>
             <a:r>
               <a:rPr lang="en-US" sz="1950" b="true">
@@ -10395,7 +10375,7 @@
                 <a:cs typeface="DM Sans Bold"/>
                 <a:sym typeface="DM Sans Bold"/>
               </a:rPr>
-              <a:t>pulmonary contusion</a:t>
+              <a:t>hypoxemia comes from the underlying contusion</a:t>
             </a:r>
           </a:p>
           <a:p>
@@ -10581,6 +10561,18 @@
               <a:buChar char="•"/>
             </a:pPr>
             <a:r>
+              <a:rPr lang="en-US" sz="1950" b="true">
+                <a:solidFill>
+                  <a:srgbClr val="FFFFFF"/>
+                </a:solidFill>
+                <a:latin typeface="DM Sans Bold"/>
+                <a:ea typeface="DM Sans Bold"/>
+                <a:cs typeface="DM Sans Bold"/>
+                <a:sym typeface="DM Sans Bold"/>
+              </a:rPr>
+              <a:t>Main killer = pneumonia</a:t>
+            </a:r>
+            <a:r>
               <a:rPr lang="en-US" sz="1950">
                 <a:solidFill>
                   <a:srgbClr val="FFFFFF"/>
@@ -10590,7 +10582,7 @@
                 <a:cs typeface="DM Sans"/>
                 <a:sym typeface="DM Sans"/>
               </a:rPr>
-              <a:t>Core treatment: </a:t>
+              <a:t> from pain → </a:t>
             </a:r>
             <a:r>
               <a:rPr lang="en-US" sz="1950" b="true">
@@ -10602,43 +10594,7 @@
                 <a:cs typeface="DM Sans Bold"/>
                 <a:sym typeface="DM Sans Bold"/>
               </a:rPr>
-              <a:t>pain control</a:t>
-            </a:r>
-            <a:r>
-              <a:rPr lang="en-US" sz="1950">
-                <a:solidFill>
-                  <a:srgbClr val="FFFFFF"/>
-                </a:solidFill>
-                <a:latin typeface="DM Sans"/>
-                <a:ea typeface="DM Sans"/>
-                <a:cs typeface="DM Sans"/>
-                <a:sym typeface="DM Sans"/>
-              </a:rPr>
-              <a:t> &amp; </a:t>
-            </a:r>
-            <a:r>
-              <a:rPr lang="en-US" sz="1950" b="true">
-                <a:solidFill>
-                  <a:srgbClr val="FFFFFF"/>
-                </a:solidFill>
-                <a:latin typeface="DM Sans Bold"/>
-                <a:ea typeface="DM Sans Bold"/>
-                <a:cs typeface="DM Sans Bold"/>
-                <a:sym typeface="DM Sans Bold"/>
-              </a:rPr>
-              <a:t>pulmonary hygiene</a:t>
-            </a:r>
-            <a:r>
-              <a:rPr lang="en-US" sz="1950">
-                <a:solidFill>
-                  <a:srgbClr val="FFFFFF"/>
-                </a:solidFill>
-                <a:latin typeface="DM Sans"/>
-                <a:ea typeface="DM Sans"/>
-                <a:cs typeface="DM Sans"/>
-                <a:sym typeface="DM Sans"/>
-              </a:rPr>
-              <a:t> (prevents pneumonia)</a:t>
+              <a:t>pain control &amp; pulmonary hygiene</a:t>
             </a:r>
           </a:p>
           <a:p>
@@ -10662,7 +10618,7 @@
                 <a:cs typeface="DM Sans Bold"/>
                 <a:sym typeface="DM Sans Bold"/>
               </a:rPr>
-              <a:t>Multimodal non-opioid analgesia</a:t>
+              <a:t>Multimodal, opioid-sparing</a:t>
             </a:r>
             <a:r>
               <a:rPr lang="en-US" sz="1950">
@@ -10674,7 +10630,7 @@
                 <a:cs typeface="DM Sans"/>
                 <a:sym typeface="DM Sans"/>
               </a:rPr>
-              <a:t> + </a:t>
+              <a:t>: paracetamol, NSAIDs, ketamine, lidocaine, </a:t>
             </a:r>
             <a:r>
               <a:rPr lang="en-US" sz="1950" b="true">
@@ -10686,7 +10642,7 @@
                 <a:cs typeface="DM Sans Bold"/>
                 <a:sym typeface="DM Sans Bold"/>
               </a:rPr>
-              <a:t>regional blocks</a:t>
+              <a:t>blocks</a:t>
             </a:r>
           </a:p>
           <a:p>
@@ -11650,6 +11606,10 @@
               <a:srgbClr val="FFDAD1"/>
             </a:solidFill>
           </p:spPr>
+          <p:txBody>
+            <a:bodyPr/>
+            <a:p/>
+          </p:txBody>
         </p:sp>
         <p:sp>
           <p:nvSpPr>
@@ -11685,7 +11645,7 @@
                   <a:cs typeface="Droid Serif Bold"/>
                   <a:sym typeface="Droid Serif Bold"/>
                 </a:rPr>
-                <a:t>Alveolar hemorrhage &amp; edema</a:t>
+                <a:t>Alveolar bleeding &amp; edema</a:t>
               </a:r>
               <a:r>
                 <a:rPr lang="en-US" sz="2100">
@@ -11697,7 +11657,7 @@
                   <a:cs typeface="Droid Serif"/>
                   <a:sym typeface="Droid Serif"/>
                 </a:rPr>
-                <a:t> without lung tear — </a:t>
+                <a:t> — </a:t>
               </a:r>
               <a:r>
                 <a:rPr lang="en-US" sz="2100" b="true">
@@ -11709,19 +11669,7 @@
                   <a:cs typeface="Droid Serif Bold"/>
                   <a:sym typeface="Droid Serif Bold"/>
                 </a:rPr>
-                <a:t>most common</a:t>
-              </a:r>
-              <a:r>
-                <a:rPr lang="en-US" sz="2100">
-                  <a:solidFill>
-                    <a:srgbClr val="E74B2F"/>
-                  </a:solidFill>
-                  <a:latin typeface="Droid Serif"/>
-                  <a:ea typeface="Droid Serif"/>
-                  <a:cs typeface="Droid Serif"/>
-                  <a:sym typeface="Droid Serif"/>
-                </a:rPr>
-                <a:t> chest injury</a:t>
+                <a:t>most common intrathoracic injury</a:t>
               </a:r>
             </a:p>
           </p:txBody>
@@ -11838,7 +11786,7 @@
         <p:grpSpPr>
           <a:xfrm rot="0">
             <a:off x="6438900" y="2351780"/>
-            <a:ext cx="10629900" cy="2448525"/>
+            <a:ext cx="10629900" cy="2860005"/>
             <a:chOff x="0" y="0"/>
             <a:chExt cx="14173200" cy="3264700"/>
           </a:xfrm>
@@ -12090,6 +12038,9 @@
               <a:lnSpc>
                 <a:spcPts val="2632"/>
               </a:lnSpc>
+              <a:spcAft>
+                <a:spcPts val="600"/>
+              </a:spcAft>
               <a:buFont typeface="Arial"/>
               <a:buChar char="•"/>
             </a:pPr>
@@ -12118,6 +12069,66 @@
               <a:t>: immediate detection; volume correlates with outcome</a:t>
             </a:r>
           </a:p>
+          <a:p>
+            <a:pPr algn="l" marL="352901" indent="-176451" lvl="1">
+              <a:lnSpc>
+                <a:spcPts val="2632"/>
+              </a:lnSpc>
+              <a:spcAft>
+                <a:spcPts val="600"/>
+              </a:spcAft>
+              <a:buFont typeface="Arial"/>
+              <a:buChar char="•"/>
+            </a:pPr>
+            <a:r>
+              <a:rPr lang="en-US" sz="1950" b="true">
+                <a:solidFill>
+                  <a:srgbClr val="1F1210"/>
+                </a:solidFill>
+                <a:latin typeface="DM Sans Bold"/>
+                <a:ea typeface="DM Sans Bold"/>
+                <a:cs typeface="DM Sans Bold"/>
+                <a:sym typeface="DM Sans Bold"/>
+              </a:rPr>
+              <a:t>Children</a:t>
+            </a:r>
+            <a:r>
+              <a:rPr lang="en-US" sz="1950">
+                <a:solidFill>
+                  <a:srgbClr val="1F1210"/>
+                </a:solidFill>
+                <a:latin typeface="DM Sans"/>
+                <a:ea typeface="DM Sans"/>
+                <a:cs typeface="DM Sans"/>
+                <a:sym typeface="DM Sans"/>
+              </a:rPr>
+              <a:t>: often </a:t>
+            </a:r>
+            <a:r>
+              <a:rPr lang="en-US" sz="1950" b="true">
+                <a:solidFill>
+                  <a:srgbClr val="1F1210"/>
+                </a:solidFill>
+                <a:latin typeface="DM Sans Bold"/>
+                <a:ea typeface="DM Sans Bold"/>
+                <a:cs typeface="DM Sans Bold"/>
+                <a:sym typeface="DM Sans Bold"/>
+              </a:rPr>
+              <a:t>no rib fracture</a:t>
+            </a:r>
+            <a:r>
+              <a:rPr lang="en-US" sz="1950">
+                <a:solidFill>
+                  <a:srgbClr val="1F1210"/>
+                </a:solidFill>
+                <a:latin typeface="DM Sans"/>
+                <a:ea typeface="DM Sans"/>
+                <a:cs typeface="DM Sans"/>
+                <a:sym typeface="DM Sans"/>
+              </a:rPr>
+              <a:t> (pliable chest wall)</a:t>
+            </a:r>
+          </a:p>
         </p:txBody>
       </p:sp>
       <p:grpSp>
@@ -12128,7 +12139,7 @@
         </p:nvGrpSpPr>
         <p:grpSpPr>
           <a:xfrm rot="0">
-            <a:off x="6438900" y="4952705"/>
+            <a:off x="6438900" y="5364185"/>
             <a:ext cx="10629900" cy="2114255"/>
             <a:chOff x="0" y="0"/>
             <a:chExt cx="14173200" cy="2819006"/>
@@ -12203,7 +12214,7 @@
         </p:nvSpPr>
         <p:spPr>
           <a:xfrm rot="0">
-            <a:off x="6705600" y="5105105"/>
+            <a:off x="6705600" y="5516585"/>
             <a:ext cx="10399395" cy="396183"/>
           </a:xfrm>
           <a:prstGeom prst="rect">
@@ -12244,7 +12255,7 @@
         </p:nvSpPr>
         <p:spPr>
           <a:xfrm rot="0">
-            <a:off x="6843141" y="5520338"/>
+            <a:off x="6843141" y="5931818"/>
             <a:ext cx="10250424" cy="1394222"/>
           </a:xfrm>
           <a:prstGeom prst="rect">
@@ -35514,7 +35525,7 @@
                 <a:cs typeface="DM Sans"/>
                 <a:sym typeface="DM Sans"/>
               </a:rPr>
-              <a:t>Right tension PTX, trachea pushed left (Fig 5-5B)</a:t>
+              <a:t>Right tension PTX, trachea → left (Fig 5-5B)</a:t>
             </a:r>
           </a:p>
         </p:txBody>
@@ -35972,7 +35983,7 @@
         <p:grpSpPr>
           <a:xfrm rot="0">
             <a:off x="6438900" y="4820250"/>
-            <a:ext cx="10629900" cy="3117056"/>
+            <a:ext cx="10629900" cy="3299936"/>
             <a:chOff x="0" y="0"/>
             <a:chExt cx="14173200" cy="4156075"/>
           </a:xfrm>
@@ -36240,7 +36251,7 @@
                 <a:cs typeface="DM Sans"/>
                 <a:sym typeface="DM Sans"/>
               </a:rPr>
-              <a:t>: 5th ICS AAL–MAL (if obese / thick chest wall)</a:t>
+              <a:t>: 5th ICS AAL–MAL (if needle fails / thick chest wall)</a:t>
             </a:r>
           </a:p>
           <a:p>
@@ -36248,6 +36259,9 @@
               <a:lnSpc>
                 <a:spcPts val="2632"/>
               </a:lnSpc>
+              <a:spcAft>
+                <a:spcPts val="600"/>
+              </a:spcAft>
               <a:buFont typeface="Arial"/>
               <a:buChar char="•"/>
             </a:pPr>
@@ -36286,6 +36300,66 @@
                 <a:sym typeface="DM Sans"/>
               </a:rPr>
               <a:t> — tension can recur</a:t>
+            </a:r>
+          </a:p>
+          <a:p>
+            <a:pPr algn="l" marL="352901" indent="-176451" lvl="1">
+              <a:lnSpc>
+                <a:spcPts val="2632"/>
+              </a:lnSpc>
+              <a:spcAft>
+                <a:spcPts val="600"/>
+              </a:spcAft>
+              <a:buFont typeface="Arial"/>
+              <a:buChar char="•"/>
+            </a:pPr>
+            <a:r>
+              <a:rPr lang="en-US" sz="1950" b="true">
+                <a:solidFill>
+                  <a:srgbClr val="FFFFFF"/>
+                </a:solidFill>
+                <a:latin typeface="DM Sans Bold"/>
+                <a:ea typeface="DM Sans Bold"/>
+                <a:cs typeface="DM Sans Bold"/>
+                <a:sym typeface="DM Sans Bold"/>
+              </a:rPr>
+              <a:t>Pregnancy</a:t>
+            </a:r>
+            <a:r>
+              <a:rPr lang="en-US" sz="1950">
+                <a:solidFill>
+                  <a:srgbClr val="FFFFFF"/>
+                </a:solidFill>
+                <a:latin typeface="DM Sans"/>
+                <a:ea typeface="DM Sans"/>
+                <a:cs typeface="DM Sans"/>
+                <a:sym typeface="DM Sans"/>
+              </a:rPr>
+              <a:t>: go 1–2 ICS higher (2nd ICS MCL) · </a:t>
+            </a:r>
+            <a:r>
+              <a:rPr lang="en-US" sz="1950" b="true">
+                <a:solidFill>
+                  <a:srgbClr val="FFFFFF"/>
+                </a:solidFill>
+                <a:latin typeface="DM Sans Bold"/>
+                <a:ea typeface="DM Sans Bold"/>
+                <a:cs typeface="DM Sans Bold"/>
+                <a:sym typeface="DM Sans Bold"/>
+              </a:rPr>
+              <a:t>Child</a:t>
+            </a:r>
+            <a:r>
+              <a:rPr lang="en-US" sz="1950">
+                <a:solidFill>
+                  <a:srgbClr val="FFFFFF"/>
+                </a:solidFill>
+                <a:latin typeface="DM Sans"/>
+                <a:ea typeface="DM Sans"/>
+                <a:cs typeface="DM Sans"/>
+                <a:sym typeface="DM Sans"/>
+              </a:rPr>
+              <a:t>: at or just above IMF</a:t>
             </a:r>
           </a:p>
         </p:txBody>
@@ -37936,7 +38010,7 @@
                 <a:cs typeface="DM Sans Bold"/>
                 <a:sym typeface="DM Sans Bold"/>
               </a:rPr>
-              <a:t>Sterile occlusive dressing</a:t>
+              <a:t>3-sided occlusive dressing</a:t>
             </a:r>
             <a:r>
               <a:rPr lang="en-US" sz="1950">
@@ -37948,31 +38022,7 @@
                 <a:cs typeface="DM Sans"/>
                 <a:sym typeface="DM Sans"/>
               </a:rPr>
-              <a:t> taped on </a:t>
-            </a:r>
-            <a:r>
-              <a:rPr lang="en-US" sz="1950" b="true">
-                <a:solidFill>
-                  <a:srgbClr val="FFFFFF"/>
-                </a:solidFill>
-                <a:latin typeface="DM Sans Bold"/>
-                <a:ea typeface="DM Sans Bold"/>
-                <a:cs typeface="DM Sans Bold"/>
-                <a:sym typeface="DM Sans Bold"/>
-              </a:rPr>
-              <a:t>3 sides</a:t>
-            </a:r>
-            <a:r>
-              <a:rPr lang="en-US" sz="1950">
-                <a:solidFill>
-                  <a:srgbClr val="FFFFFF"/>
-                </a:solidFill>
-                <a:latin typeface="DM Sans"/>
-                <a:ea typeface="DM Sans"/>
-                <a:cs typeface="DM Sans"/>
-                <a:sym typeface="DM Sans"/>
-              </a:rPr>
-              <a:t> (or vented chest seal)</a:t>
+              <a:t> = flutter valve, prevents tension (or vented seal)</a:t>
             </a:r>
           </a:p>
           <a:p>

</xml_diff>